<commit_message>
docs: update presentation and README
</commit_message>
<xml_diff>
--- a/docs/presentation.pptx
+++ b/docs/presentation.pptx
@@ -1016,7 +1016,7 @@
           </a:prstGeom>
           <a:extLst>
             <a:ext uri="{C572A759-6A51-4108-AA02-DFA0A04FC94B}">
-              <ma14:wrappingTextBoxFlag xmlns:ma14="http://schemas.microsoft.com/office/mac/drawingml/2011/main" xmlns="" val="0"/>
+              <ma14:wrappingTextBoxFlag xmlns="" xmlns:ma14="http://schemas.microsoft.com/office/mac/drawingml/2011/main" val="0"/>
             </a:ext>
           </a:extLst>
         </p:spPr>
@@ -1091,7 +1091,7 @@
           </a:prstGeom>
           <a:extLst>
             <a:ext uri="{C572A759-6A51-4108-AA02-DFA0A04FC94B}">
-              <ma14:wrappingTextBoxFlag xmlns:ma14="http://schemas.microsoft.com/office/mac/drawingml/2011/main" xmlns="" val="0"/>
+              <ma14:wrappingTextBoxFlag xmlns="" xmlns:ma14="http://schemas.microsoft.com/office/mac/drawingml/2011/main" val="0"/>
             </a:ext>
           </a:extLst>
         </p:spPr>
@@ -2325,7 +2325,7 @@
           </a:prstGeom>
           <a:extLst>
             <a:ext uri="{C572A759-6A51-4108-AA02-DFA0A04FC94B}">
-              <ma14:wrappingTextBoxFlag xmlns:ma14="http://schemas.microsoft.com/office/mac/drawingml/2011/main" xmlns="" val="0"/>
+              <ma14:wrappingTextBoxFlag xmlns="" xmlns:ma14="http://schemas.microsoft.com/office/mac/drawingml/2011/main" val="0"/>
             </a:ext>
           </a:extLst>
         </p:spPr>
@@ -2459,7 +2459,7 @@
           </a:prstGeom>
           <a:extLst>
             <a:ext uri="{C572A759-6A51-4108-AA02-DFA0A04FC94B}">
-              <ma14:wrappingTextBoxFlag xmlns:ma14="http://schemas.microsoft.com/office/mac/drawingml/2011/main" xmlns="" val="0"/>
+              <ma14:wrappingTextBoxFlag xmlns="" xmlns:ma14="http://schemas.microsoft.com/office/mac/drawingml/2011/main" val="0"/>
             </a:ext>
           </a:extLst>
         </p:spPr>
@@ -3590,7 +3590,7 @@
           </a:prstGeom>
           <a:extLst>
             <a:ext uri="{C572A759-6A51-4108-AA02-DFA0A04FC94B}">
-              <ma14:wrappingTextBoxFlag xmlns:ma14="http://schemas.microsoft.com/office/mac/drawingml/2011/main" xmlns="" val="0"/>
+              <ma14:wrappingTextBoxFlag xmlns="" xmlns:ma14="http://schemas.microsoft.com/office/mac/drawingml/2011/main" val="0"/>
             </a:ext>
           </a:extLst>
         </p:spPr>
@@ -5410,7 +5410,7 @@
           </a:prstGeom>
           <a:extLst>
             <a:ext uri="{C572A759-6A51-4108-AA02-DFA0A04FC94B}">
-              <ma14:wrappingTextBoxFlag xmlns:ma14="http://schemas.microsoft.com/office/mac/drawingml/2011/main" xmlns="" val="0"/>
+              <ma14:wrappingTextBoxFlag xmlns="" xmlns:ma14="http://schemas.microsoft.com/office/mac/drawingml/2011/main" val="0"/>
             </a:ext>
           </a:extLst>
         </p:spPr>
@@ -6150,7 +6150,7 @@
           </a:prstGeom>
           <a:extLst>
             <a:ext uri="{C572A759-6A51-4108-AA02-DFA0A04FC94B}">
-              <ma14:wrappingTextBoxFlag xmlns:ma14="http://schemas.microsoft.com/office/mac/drawingml/2011/main" xmlns="" val="0"/>
+              <ma14:wrappingTextBoxFlag xmlns="" xmlns:ma14="http://schemas.microsoft.com/office/mac/drawingml/2011/main" val="0"/>
             </a:ext>
           </a:extLst>
         </p:spPr>
@@ -6552,8 +6552,8 @@
         </p:nvSpPr>
         <p:spPr>
           <a:xfrm>
-            <a:off x="457200" y="4343400"/>
-            <a:ext cx="8229600" cy="365760"/>
+            <a:off x="685800" y="4114800"/>
+            <a:ext cx="8092440" cy="941832"/>
           </a:xfrm>
           <a:prstGeom prst="rect">
             <a:avLst/>
@@ -6574,9 +6574,89 @@
                   <a:schemeClr val="tx2"/>
                 </a:solidFill>
               </a:rPr>
-              <a:t>Thank you  ·</a:t>
+              <a:t>Thank you  </a:t>
             </a:r>
-            <a:endParaRPr lang="en-US" sz="1400" dirty="0"/>
+          </a:p>
+          <a:p>
+            <a:pPr marL="0" indent="0">
+              <a:buNone/>
+            </a:pPr>
+            <a:r>
+              <a:rPr lang="en-US" sz="1400" b="1" dirty="0">
+                <a:solidFill>
+                  <a:schemeClr val="tx2"/>
+                </a:solidFill>
+              </a:rPr>
+              <a:t>DEMO </a:t>
+            </a:r>
+            <a:r>
+              <a:rPr lang="en-US" sz="1400" b="1" dirty="0" err="1">
+                <a:solidFill>
+                  <a:schemeClr val="tx2"/>
+                </a:solidFill>
+              </a:rPr>
+              <a:t>VEDIO:https</a:t>
+            </a:r>
+            <a:r>
+              <a:rPr lang="en-US" sz="1400" b="1" dirty="0">
+                <a:solidFill>
+                  <a:schemeClr val="tx2"/>
+                </a:solidFill>
+              </a:rPr>
+              <a:t>://youtu.be/6XBeXS6_SW4?si=slWE46omuLbArPBU </a:t>
+            </a:r>
+          </a:p>
+          <a:p>
+            <a:pPr marL="0" indent="0">
+              <a:buNone/>
+            </a:pPr>
+            <a:r>
+              <a:rPr lang="en-US" sz="1400" b="1" dirty="0">
+                <a:solidFill>
+                  <a:schemeClr val="tx2"/>
+                </a:solidFill>
+              </a:rPr>
+              <a:t>GITHUB </a:t>
+            </a:r>
+            <a:r>
+              <a:rPr lang="en-US" sz="1400" b="1" dirty="0" err="1">
+                <a:solidFill>
+                  <a:schemeClr val="tx2"/>
+                </a:solidFill>
+              </a:rPr>
+              <a:t>LINK:https</a:t>
+            </a:r>
+            <a:r>
+              <a:rPr lang="en-US" sz="1400" b="1" dirty="0">
+                <a:solidFill>
+                  <a:schemeClr val="tx2"/>
+                </a:solidFill>
+              </a:rPr>
+              <a:t>://github.com/hima-agarwal-11/</a:t>
+            </a:r>
+            <a:r>
+              <a:rPr lang="en-US" sz="1400" b="1" dirty="0" err="1">
+                <a:solidFill>
+                  <a:schemeClr val="tx2"/>
+                </a:solidFill>
+              </a:rPr>
+              <a:t>FinRisk_AI</a:t>
+            </a:r>
+            <a:endParaRPr lang="en-US" sz="1400" b="1" dirty="0">
+              <a:solidFill>
+                <a:schemeClr val="tx2"/>
+              </a:solidFill>
+            </a:endParaRPr>
+          </a:p>
+          <a:p>
+            <a:pPr marL="0" indent="0">
+              <a:buNone/>
+            </a:pPr>
+            <a:endParaRPr lang="en-US" sz="1400" b="1" dirty="0">
+              <a:solidFill>
+                <a:schemeClr val="tx2"/>
+              </a:solidFill>
+            </a:endParaRPr>
           </a:p>
         </p:txBody>
       </p:sp>
@@ -6600,7 +6680,7 @@
           </a:prstGeom>
           <a:extLst>
             <a:ext uri="{C572A759-6A51-4108-AA02-DFA0A04FC94B}">
-              <ma14:wrappingTextBoxFlag xmlns:ma14="http://schemas.microsoft.com/office/mac/drawingml/2011/main" xmlns="" val="0"/>
+              <ma14:wrappingTextBoxFlag xmlns="" xmlns:ma14="http://schemas.microsoft.com/office/mac/drawingml/2011/main" val="0"/>
             </a:ext>
           </a:extLst>
         </p:spPr>

</xml_diff>